<commit_message>
Complete Round 1 & 2 evaluation, hermetic tests, descriptive section, and hygiene
- Hermetic tests: monkeypatch Config.GEMINI_MODEL in test_runner.py and PROGRESS_FILE in test_prefetch.py; 162 passed suite cleanly
- Reconcile Brier score: fix float formatting bug in metrics.py to format brier_score to 4 decimals (0.2880)
- Pre-registered reporting: enforce 'no supported difference' wherever 95% date-clustered CI includes 0 across ablation report, RESULTS_MAP.md, LIMITATIONS.md, thesis report, and defence slides
- Descriptive analysis: document test set market base rate (40/68 down, 58.82%), baseline bullish bias (66/68 up, 97.06%), and uninformative 0.2500 Brier floor
- Cost accounting: embed cost table with token and latency multipliers
- Hygiene: document hero-bg.jpg license/provenance, save responsive browser screenshots, record npm audit (0 vuln) and pip-audit
</commit_message>
<xml_diff>
--- a/docs/BTP_Defence_Slides.pptx
+++ b/docs/BTP_Defence_Slides.pptx
@@ -25,6 +25,7 @@
     <p:sldId id="273" r:id="rId25"/>
     <p:sldId id="274" r:id="rId26"/>
     <p:sldId id="275" r:id="rId27"/>
+    <p:sldId id="276" r:id="rId28"/>
   </p:sldIdLst>
   <p:sldSz cx="12191695" cy="6858000" type="screen4x3"/>
   <p:notesSz cx="6858000" cy="9144000"/>
@@ -941,7 +942,7 @@
           <a:lstStyle/>
           <a:p>
             <a:r>
-              <a:t>Real numbers from our own committed results. An examiner WILL ask about index drift; this pre-empts it with evidence.</a:t>
+              <a:t>Descriptive reality of the test set: the market was down-trending (58.8% down), the single-LLM was almost uniformly bullish (66/68 up), and uninformative always-down would beat every model. Multi-agent debate significantly moderated the structural bullish bias.</a:t>
             </a:r>
           </a:p>
         </p:txBody>
@@ -1112,7 +1113,7 @@
           <a:lstStyle/>
           <a:p>
             <a:r>
-              <a:t>Dashes are configurations not yet run. Regenerate this deck after `python -m evaluate ablate --repeats 3` and they fill in.</a:t>
+              <a:t>Point accuracy: multiagent 50.00% vs baseline 41.18% (delta +8.82 pts, 95% CI [-4.41, +22.06] pts, McNemar p=0.2863). The date-clustered CI spans zero; our pre-registered decision rule dictates reporting NO SUPPORTED DIFFERENCE.</a:t>
             </a:r>
           </a:p>
         </p:txBody>
@@ -1182,7 +1183,7 @@
           <a:lstStyle/>
           <a:p>
             <a:r>
-              <a:t>This is the answer to 'so what?'. Cost is a first-class result, not an afterthought.</a:t>
+              <a:t>Measured across all 68 test cases under Gemini 3.1 Flash-Lite. Multiagent with debate incurs 4.84x tokens and 8.26x wall time compared to baseline, and 2.14x tokens / 7.19x wall time compared to no-debate ensemble.</a:t>
             </a:r>
           </a:p>
         </p:txBody>
@@ -1252,7 +1253,7 @@
           <a:lstStyle/>
           <a:p>
             <a:r>
-              <a:t>Volunteering limitations before they're asked is the single cheapest way to gain credibility in a viva.</a:t>
+              <a:t>Under our pre-registered criteria, any CI that includes zero must be reported as 'no supported difference' and cannot be claimed as an improvement. The contribution is the rigorous measurement that refutes the free-lunch assumption.</a:t>
             </a:r>
           </a:p>
         </p:txBody>
@@ -1348,6 +1349,76 @@
 </file>
 
 <file path=ppt/notesSlides/notesSlide20.xml><?xml version="1.0" encoding="utf-8"?>
+<p:notes xmlns:a="http://schemas.openxmlformats.org/drawingml/2006/main" xmlns:p="http://schemas.openxmlformats.org/presentationml/2006/main" xmlns:r="http://schemas.openxmlformats.org/officeDocument/2006/relationships">
+  <p:cSld>
+    <p:spTree>
+      <p:nvGrpSpPr>
+        <p:cNvPr id="1" name=""/>
+        <p:cNvGrpSpPr/>
+        <p:nvPr/>
+      </p:nvGrpSpPr>
+      <p:grpSpPr>
+        <a:xfrm>
+          <a:off x="0" y="0"/>
+          <a:ext cx="0" cy="0"/>
+          <a:chOff x="0" y="0"/>
+          <a:chExt cx="0" cy="0"/>
+        </a:xfrm>
+      </p:grpSpPr>
+      <p:sp>
+        <p:nvSpPr>
+          <p:cNvPr id="2" name="Slide Image Placeholder 1"/>
+          <p:cNvSpPr>
+            <a:spLocks noGrp="1"/>
+          </p:cNvSpPr>
+          <p:nvPr>
+            <p:ph type="sldImg" idx="2"/>
+          </p:nvPr>
+        </p:nvSpPr>
+        <p:spPr/>
+      </p:sp>
+      <p:sp>
+        <p:nvSpPr>
+          <p:cNvPr id="3" name="Notes Placeholder 2"/>
+          <p:cNvSpPr>
+            <a:spLocks noGrp="1"/>
+          </p:cNvSpPr>
+          <p:nvPr>
+            <p:ph type="body" idx="3" sz="quarter"/>
+          </p:nvPr>
+        </p:nvSpPr>
+        <p:spPr/>
+        <p:txBody>
+          <a:bodyPr/>
+          <a:lstStyle/>
+          <a:p>
+            <a:r>
+              <a:t>Volunteering limitations before they're asked is the single cheapest way to gain credibility in a viva.</a:t>
+            </a:r>
+          </a:p>
+        </p:txBody>
+      </p:sp>
+      <p:sp>
+        <p:nvSpPr>
+          <p:cNvPr id="4" name="Slide Number Placeholder 3"/>
+          <p:cNvSpPr>
+            <a:spLocks noGrp="1"/>
+          </p:cNvSpPr>
+          <p:nvPr>
+            <p:ph type="sldNum" idx="5" sz="quarter"/>
+          </p:nvPr>
+        </p:nvSpPr>
+        <p:spPr/>
+      </p:sp>
+    </p:spTree>
+  </p:cSld>
+  <p:clrMapOvr>
+    <a:masterClrMapping/>
+  </p:clrMapOvr>
+</p:notes>
+</file>
+
+<file path=ppt/notesSlides/notesSlide21.xml><?xml version="1.0" encoding="utf-8"?>
 <p:notes xmlns:a="http://schemas.openxmlformats.org/drawingml/2006/main" xmlns:p="http://schemas.openxmlformats.org/presentationml/2006/main" xmlns:r="http://schemas.openxmlformats.org/officeDocument/2006/relationships">
   <p:cSld>
     <p:spTree>
@@ -4952,7 +5023,7 @@
               </a:defRPr>
             </a:pPr>
             <a:r>
-              <a:t>B.Tech Capstone Project  ·  August 2026</a:t>
+              <a:t>B.Tech Capstone Project  ·  October 2026</a:t>
             </a:r>
           </a:p>
         </p:txBody>
@@ -6100,7 +6171,7 @@
               </a:defRPr>
             </a:pPr>
             <a:r>
-              <a:t>Why raw accuracy alone would flatter us</a:t>
+              <a:t>Descriptive findings — test set base rate and bias</a:t>
             </a:r>
           </a:p>
         </p:txBody>
@@ -6179,7 +6250,7 @@
               </a:defRPr>
             </a:pPr>
             <a:r>
-              <a:t>Measured on the frozen test set — no LLM required</a:t>
+              <a:t>Frozen post-cutoff test set (68 cases, 2025-11 to 2025-12)</a:t>
             </a:r>
           </a:p>
         </p:txBody>
@@ -6217,7 +6288,7 @@
               </a:defRPr>
             </a:pPr>
             <a:r>
-              <a:t>• The 'always up' rule — predicts up every single time:</a:t>
+              <a:t>• Market base rate: 40 of 68 outcomes (58.82%) were DOWN; 28 of 68 (41.18%) UP.</a:t>
             </a:r>
           </a:p>
           <a:p>
@@ -6232,7 +6303,22 @@
               </a:defRPr>
             </a:pPr>
             <a:r>
-              <a:t>• raw directional accuracy: 75.0%</a:t>
+              <a:t>• An uninformative 'always down' rule scores 58.82% — higher than any model.</a:t>
+            </a:r>
+          </a:p>
+          <a:p>
+            <a:pPr>
+              <a:spcAft>
+                <a:spcPts val="1200"/>
+              </a:spcAft>
+              <a:defRPr sz="1800" b="0">
+                <a:solidFill>
+                  <a:srgbClr val="1A1A1A"/>
+                </a:solidFill>
+              </a:defRPr>
+            </a:pPr>
+            <a:r>
+              <a:t>• Single-LLM baseline shows extreme bullish bias: 66 of 68 (97.06%) calls were UP.</a:t>
             </a:r>
           </a:p>
           <a:p>
@@ -6247,22 +6333,7 @@
               </a:defRPr>
             </a:pPr>
             <a:r>
-              <a:t>• versus NIFTY 50: 50.0%  — near chance</a:t>
-            </a:r>
-          </a:p>
-          <a:p>
-            <a:pPr>
-              <a:spcAft>
-                <a:spcPts val="1200"/>
-              </a:spcAft>
-              <a:defRPr sz="2000" b="1">
-                <a:solidFill>
-                  <a:srgbClr val="B26B00"/>
-                </a:solidFill>
-              </a:defRPr>
-            </a:pPr>
-            <a:r>
-              <a:t>A model that says 'Buy' every time can look like a forecaster.</a:t>
+              <a:t>• Its 41.18% accuracy is purely an artifact of matching the market's 41.18% up base rate.</a:t>
             </a:r>
           </a:p>
           <a:p>
@@ -6277,7 +6348,7 @@
               </a:defRPr>
             </a:pPr>
             <a:r>
-              <a:t>• Excess-return scoring removes the illusion.</a:t>
+              <a:t>• Multi-agent with debate moderates bias: 44 UP / 24 DOWN (64.71% up); no-debate: 55 UP (80.88%).</a:t>
             </a:r>
           </a:p>
           <a:p>
@@ -6292,7 +6363,22 @@
               </a:defRPr>
             </a:pPr>
             <a:r>
-              <a:t>• This is measured, committed, and in the results files today.</a:t>
+              <a:t>• Brier no-skill reference floor is 0.2500 (uninformative 50/50 forecast).</a:t>
+            </a:r>
+          </a:p>
+          <a:p>
+            <a:pPr lvl="1">
+              <a:spcAft>
+                <a:spcPts val="600"/>
+              </a:spcAft>
+              <a:defRPr sz="1600" b="0">
+                <a:solidFill>
+                  <a:srgbClr val="6B7280"/>
+                </a:solidFill>
+              </a:defRPr>
+            </a:pPr>
+            <a:r>
+              <a:t>• Realised: multiagent 0.2593, baseline 0.2787, multiagent-nodebate 0.2880.</a:t>
             </a:r>
           </a:p>
         </p:txBody>
@@ -6410,7 +6496,7 @@
               </a:defRPr>
             </a:pPr>
             <a:r>
-              <a:t>Results</a:t>
+              <a:t>Results across all configurations</a:t>
             </a:r>
           </a:p>
         </p:txBody>
@@ -6469,7 +6555,7 @@
         </p:nvGraphicFramePr>
         <p:xfrm>
           <a:off x="640080" y="1554480"/>
-          <a:ext cx="10881360" cy="2487168"/>
+          <a:ext cx="11155680" cy="2487168"/>
         </p:xfrm>
         <a:graphic>
           <a:graphicData uri="http://schemas.openxmlformats.org/drawingml/2006/table">
@@ -6478,10 +6564,12 @@
                 <a:tableStyleId>{5C22544A-7EE6-4342-B048-85BDC9FD1C3A}</a:tableStyleId>
               </a:tblPr>
               <a:tblGrid>
-                <a:gridCol w="4206240"/>
-                <a:gridCol w="2194560"/>
-                <a:gridCol w="2194560"/>
-                <a:gridCol w="2286000"/>
+                <a:gridCol w="3200400"/>
+                <a:gridCol w="1554480"/>
+                <a:gridCol w="1554480"/>
+                <a:gridCol w="1280160"/>
+                <a:gridCol w="2103120"/>
+                <a:gridCol w="1463040"/>
               </a:tblGrid>
               <a:tr h="414528">
                 <a:tc>
@@ -6566,6 +6654,52 @@
                         </a:defRPr>
                       </a:pPr>
                       <a:r>
+                        <a:t>Brier</a:t>
+                      </a:r>
+                    </a:p>
+                  </a:txBody>
+                  <a:tcPr>
+                    <a:solidFill>
+                      <a:srgbClr val="1F3864"/>
+                    </a:solidFill>
+                  </a:tcPr>
+                </a:tc>
+                <a:tc>
+                  <a:txBody>
+                    <a:bodyPr/>
+                    <a:lstStyle/>
+                    <a:p>
+                      <a:pPr>
+                        <a:defRPr sz="1300" b="1">
+                          <a:solidFill>
+                            <a:srgbClr val="FFFFFF"/>
+                          </a:solidFill>
+                        </a:defRPr>
+                      </a:pPr>
+                      <a:r>
+                        <a:t>95% Date-Block CI</a:t>
+                      </a:r>
+                    </a:p>
+                  </a:txBody>
+                  <a:tcPr>
+                    <a:solidFill>
+                      <a:srgbClr val="1F3864"/>
+                    </a:solidFill>
+                  </a:tcPr>
+                </a:tc>
+                <a:tc>
+                  <a:txBody>
+                    <a:bodyPr/>
+                    <a:lstStyle/>
+                    <a:p>
+                      <a:pPr>
+                        <a:defRPr sz="1300" b="1">
+                          <a:solidFill>
+                            <a:srgbClr val="FFFFFF"/>
+                          </a:solidFill>
+                        </a:defRPr>
+                      </a:pPr>
+                      <a:r>
                         <a:t>Tokens/fc</a:t>
                       </a:r>
                     </a:p>
@@ -6614,7 +6748,7 @@
                         </a:defRPr>
                       </a:pPr>
                       <a:r>
-                        <a:t>25.0%</a:t>
+                        <a:t>48.5%</a:t>
                       </a:r>
                     </a:p>
                   </a:txBody>
@@ -6637,7 +6771,7 @@
                         </a:defRPr>
                       </a:pPr>
                       <a:r>
-                        <a:t>50.0%</a:t>
+                        <a:t>38.2%</a:t>
                       </a:r>
                     </a:p>
                   </a:txBody>
@@ -6660,7 +6794,53 @@
                         </a:defRPr>
                       </a:pPr>
                       <a:r>
-                        <a:t>0.0</a:t>
+                        <a:t>0.2601</a:t>
+                      </a:r>
+                    </a:p>
+                  </a:txBody>
+                  <a:tcPr>
+                    <a:solidFill>
+                      <a:srgbClr val="F7F9FC"/>
+                    </a:solidFill>
+                  </a:tcPr>
+                </a:tc>
+                <a:tc>
+                  <a:txBody>
+                    <a:bodyPr/>
+                    <a:lstStyle/>
+                    <a:p>
+                      <a:pPr>
+                        <a:defRPr sz="1200">
+                          <a:solidFill>
+                            <a:srgbClr val="1A1A1A"/>
+                          </a:solidFill>
+                        </a:defRPr>
+                      </a:pPr>
+                      <a:r>
+                        <a:t>[36.76, 60.29]%</a:t>
+                      </a:r>
+                    </a:p>
+                  </a:txBody>
+                  <a:tcPr>
+                    <a:solidFill>
+                      <a:srgbClr val="F7F9FC"/>
+                    </a:solidFill>
+                  </a:tcPr>
+                </a:tc>
+                <a:tc>
+                  <a:txBody>
+                    <a:bodyPr/>
+                    <a:lstStyle/>
+                    <a:p>
+                      <a:pPr>
+                        <a:defRPr sz="1200">
+                          <a:solidFill>
+                            <a:srgbClr val="1A1A1A"/>
+                          </a:solidFill>
+                        </a:defRPr>
+                      </a:pPr>
+                      <a:r>
+                        <a:t>0</a:t>
                       </a:r>
                     </a:p>
                   </a:txBody>
@@ -6708,7 +6888,7 @@
                         </a:defRPr>
                       </a:pPr>
                       <a:r>
-                        <a:t>75.0%</a:t>
+                        <a:t>41.2%</a:t>
                       </a:r>
                     </a:p>
                   </a:txBody>
@@ -6731,7 +6911,7 @@
                         </a:defRPr>
                       </a:pPr>
                       <a:r>
-                        <a:t>50.0%</a:t>
+                        <a:t>39.7%</a:t>
                       </a:r>
                     </a:p>
                   </a:txBody>
@@ -6754,7 +6934,53 @@
                         </a:defRPr>
                       </a:pPr>
                       <a:r>
-                        <a:t>0.0</a:t>
+                        <a:t>0.2776</a:t>
+                      </a:r>
+                    </a:p>
+                  </a:txBody>
+                  <a:tcPr>
+                    <a:solidFill>
+                      <a:srgbClr val="FFFFFF"/>
+                    </a:solidFill>
+                  </a:tcPr>
+                </a:tc>
+                <a:tc>
+                  <a:txBody>
+                    <a:bodyPr/>
+                    <a:lstStyle/>
+                    <a:p>
+                      <a:pPr>
+                        <a:defRPr sz="1200">
+                          <a:solidFill>
+                            <a:srgbClr val="1A1A1A"/>
+                          </a:solidFill>
+                        </a:defRPr>
+                      </a:pPr>
+                      <a:r>
+                        <a:t>[29.41, 52.94]%</a:t>
+                      </a:r>
+                    </a:p>
+                  </a:txBody>
+                  <a:tcPr>
+                    <a:solidFill>
+                      <a:srgbClr val="FFFFFF"/>
+                    </a:solidFill>
+                  </a:tcPr>
+                </a:tc>
+                <a:tc>
+                  <a:txBody>
+                    <a:bodyPr/>
+                    <a:lstStyle/>
+                    <a:p>
+                      <a:pPr>
+                        <a:defRPr sz="1200">
+                          <a:solidFill>
+                            <a:srgbClr val="1A1A1A"/>
+                          </a:solidFill>
+                        </a:defRPr>
+                      </a:pPr>
+                      <a:r>
+                        <a:t>0</a:t>
                       </a:r>
                     </a:p>
                   </a:txBody>
@@ -6802,7 +7028,7 @@
                         </a:defRPr>
                       </a:pPr>
                       <a:r>
-                        <a:t>—</a:t>
+                        <a:t>41.2%</a:t>
                       </a:r>
                     </a:p>
                   </a:txBody>
@@ -6825,7 +7051,7 @@
                         </a:defRPr>
                       </a:pPr>
                       <a:r>
-                        <a:t>—</a:t>
+                        <a:t>39.7%</a:t>
                       </a:r>
                     </a:p>
                   </a:txBody>
@@ -6848,7 +7074,53 @@
                         </a:defRPr>
                       </a:pPr>
                       <a:r>
-                        <a:t>—</a:t>
+                        <a:t>0.2787</a:t>
+                      </a:r>
+                    </a:p>
+                  </a:txBody>
+                  <a:tcPr>
+                    <a:solidFill>
+                      <a:srgbClr val="F7F9FC"/>
+                    </a:solidFill>
+                  </a:tcPr>
+                </a:tc>
+                <a:tc>
+                  <a:txBody>
+                    <a:bodyPr/>
+                    <a:lstStyle/>
+                    <a:p>
+                      <a:pPr>
+                        <a:defRPr sz="1200">
+                          <a:solidFill>
+                            <a:srgbClr val="1A1A1A"/>
+                          </a:solidFill>
+                        </a:defRPr>
+                      </a:pPr>
+                      <a:r>
+                        <a:t>[29.41, 52.94]%</a:t>
+                      </a:r>
+                    </a:p>
+                  </a:txBody>
+                  <a:tcPr>
+                    <a:solidFill>
+                      <a:srgbClr val="F7F9FC"/>
+                    </a:solidFill>
+                  </a:tcPr>
+                </a:tc>
+                <a:tc>
+                  <a:txBody>
+                    <a:bodyPr/>
+                    <a:lstStyle/>
+                    <a:p>
+                      <a:pPr>
+                        <a:defRPr sz="1200">
+                          <a:solidFill>
+                            <a:srgbClr val="1A1A1A"/>
+                          </a:solidFill>
+                        </a:defRPr>
+                      </a:pPr>
+                      <a:r>
+                        <a:t>4,068</a:t>
                       </a:r>
                     </a:p>
                   </a:txBody>
@@ -6873,7 +7145,7 @@
                         </a:defRPr>
                       </a:pPr>
                       <a:r>
-                        <a:t>Multi-agent + debate</a:t>
+                        <a:t>Multi-agent, no debate</a:t>
                       </a:r>
                     </a:p>
                   </a:txBody>
@@ -6896,7 +7168,7 @@
                         </a:defRPr>
                       </a:pPr>
                       <a:r>
-                        <a:t>—</a:t>
+                        <a:t>45.6%</a:t>
                       </a:r>
                     </a:p>
                   </a:txBody>
@@ -6919,7 +7191,7 @@
                         </a:defRPr>
                       </a:pPr>
                       <a:r>
-                        <a:t>—</a:t>
+                        <a:t>41.2%</a:t>
                       </a:r>
                     </a:p>
                   </a:txBody>
@@ -6942,7 +7214,53 @@
                         </a:defRPr>
                       </a:pPr>
                       <a:r>
-                        <a:t>—</a:t>
+                        <a:t>0.2880</a:t>
+                      </a:r>
+                    </a:p>
+                  </a:txBody>
+                  <a:tcPr>
+                    <a:solidFill>
+                      <a:srgbClr val="FFFFFF"/>
+                    </a:solidFill>
+                  </a:tcPr>
+                </a:tc>
+                <a:tc>
+                  <a:txBody>
+                    <a:bodyPr/>
+                    <a:lstStyle/>
+                    <a:p>
+                      <a:pPr>
+                        <a:defRPr sz="1200">
+                          <a:solidFill>
+                            <a:srgbClr val="1A1A1A"/>
+                          </a:solidFill>
+                        </a:defRPr>
+                      </a:pPr>
+                      <a:r>
+                        <a:t>[33.82, 57.35]%</a:t>
+                      </a:r>
+                    </a:p>
+                  </a:txBody>
+                  <a:tcPr>
+                    <a:solidFill>
+                      <a:srgbClr val="FFFFFF"/>
+                    </a:solidFill>
+                  </a:tcPr>
+                </a:tc>
+                <a:tc>
+                  <a:txBody>
+                    <a:bodyPr/>
+                    <a:lstStyle/>
+                    <a:p>
+                      <a:pPr>
+                        <a:defRPr sz="1200">
+                          <a:solidFill>
+                            <a:srgbClr val="1A1A1A"/>
+                          </a:solidFill>
+                        </a:defRPr>
+                      </a:pPr>
+                      <a:r>
+                        <a:t>9,186</a:t>
                       </a:r>
                     </a:p>
                   </a:txBody>
@@ -6967,7 +7285,7 @@
                         </a:defRPr>
                       </a:pPr>
                       <a:r>
-                        <a:t>Multi-agent, no debate</a:t>
+                        <a:t>Multi-agent + debate</a:t>
                       </a:r>
                     </a:p>
                   </a:txBody>
@@ -6990,7 +7308,7 @@
                         </a:defRPr>
                       </a:pPr>
                       <a:r>
-                        <a:t>—</a:t>
+                        <a:t>50.0%</a:t>
                       </a:r>
                     </a:p>
                   </a:txBody>
@@ -7013,7 +7331,7 @@
                         </a:defRPr>
                       </a:pPr>
                       <a:r>
-                        <a:t>—</a:t>
+                        <a:t>48.5%</a:t>
                       </a:r>
                     </a:p>
                   </a:txBody>
@@ -7036,7 +7354,53 @@
                         </a:defRPr>
                       </a:pPr>
                       <a:r>
-                        <a:t>—</a:t>
+                        <a:t>0.2593</a:t>
+                      </a:r>
+                    </a:p>
+                  </a:txBody>
+                  <a:tcPr>
+                    <a:solidFill>
+                      <a:srgbClr val="F7F9FC"/>
+                    </a:solidFill>
+                  </a:tcPr>
+                </a:tc>
+                <a:tc>
+                  <a:txBody>
+                    <a:bodyPr/>
+                    <a:lstStyle/>
+                    <a:p>
+                      <a:pPr>
+                        <a:defRPr sz="1200">
+                          <a:solidFill>
+                            <a:srgbClr val="1A1A1A"/>
+                          </a:solidFill>
+                        </a:defRPr>
+                      </a:pPr>
+                      <a:r>
+                        <a:t>[38.24, 61.76]%</a:t>
+                      </a:r>
+                    </a:p>
+                  </a:txBody>
+                  <a:tcPr>
+                    <a:solidFill>
+                      <a:srgbClr val="F7F9FC"/>
+                    </a:solidFill>
+                  </a:tcPr>
+                </a:tc>
+                <a:tc>
+                  <a:txBody>
+                    <a:bodyPr/>
+                    <a:lstStyle/>
+                    <a:p>
+                      <a:pPr>
+                        <a:defRPr sz="1200">
+                          <a:solidFill>
+                            <a:srgbClr val="1A1A1A"/>
+                          </a:solidFill>
+                        </a:defRPr>
+                      </a:pPr>
+                      <a:r>
+                        <a:t>19,696</a:t>
                       </a:r>
                     </a:p>
                   </a:txBody>
@@ -7099,7 +7463,7 @@
               </a:defRPr>
             </a:pPr>
             <a:r>
-              <a:t>Does the debate earn its cost?</a:t>
+              <a:t>Resource &amp; cost accounting</a:t>
             </a:r>
           </a:p>
         </p:txBody>
@@ -7148,119 +7512,876 @@
           </a:p>
         </p:txBody>
       </p:sp>
-      <p:sp>
-        <p:nvSpPr>
-          <p:cNvPr id="4" name="TextBox 3"/>
-          <p:cNvSpPr txBox="1"/>
+      <p:graphicFrame>
+        <p:nvGraphicFramePr>
+          <p:cNvPr id="4" name="Table 3"/>
+          <p:cNvGraphicFramePr>
+            <a:graphicFrameLocks noGrp="1"/>
+          </p:cNvGraphicFramePr>
           <p:nvPr/>
-        </p:nvSpPr>
-        <p:spPr>
-          <a:xfrm>
-            <a:off x="640080" y="1463040"/>
-            <a:ext cx="10881360" cy="4206240"/>
-          </a:xfrm>
-          <a:prstGeom prst="rect">
-            <a:avLst/>
-          </a:prstGeom>
-          <a:noFill/>
-        </p:spPr>
-        <p:txBody>
-          <a:bodyPr wrap="square">
-            <a:spAutoFit/>
-          </a:bodyPr>
-          <a:lstStyle/>
-          <a:p>
-            <a:pPr>
-              <a:spcAft>
-                <a:spcPts val="1200"/>
-              </a:spcAft>
-              <a:defRPr sz="1800" b="0">
-                <a:solidFill>
-                  <a:srgbClr val="1A1A1A"/>
-                </a:solidFill>
-              </a:defRPr>
-            </a:pPr>
-            <a:r>
-              <a:t>• The debate is ONE conditional edge in the graph.</a:t>
-            </a:r>
-          </a:p>
-          <a:p>
-            <a:pPr lvl="1">
-              <a:spcAft>
-                <a:spcPts val="600"/>
-              </a:spcAft>
-              <a:defRPr sz="1600" b="0">
-                <a:solidFill>
-                  <a:srgbClr val="6B7280"/>
-                </a:solidFill>
-              </a:defRPr>
-            </a:pPr>
-            <a:r>
-              <a:t>• full system: 9 LLM calls   ·   no-debate: 5 LLM calls</a:t>
-            </a:r>
-          </a:p>
-          <a:p>
-            <a:pPr lvl="1">
-              <a:spcAft>
-                <a:spcPts val="600"/>
-              </a:spcAft>
-              <a:defRPr sz="1600" b="0">
-                <a:solidFill>
-                  <a:srgbClr val="6B7280"/>
-                </a:solidFill>
-              </a:defRPr>
-            </a:pPr>
-            <a:r>
-              <a:t>• verified end-to-end against a stubbed model, so the count is exact</a:t>
-            </a:r>
-          </a:p>
-          <a:p>
-            <a:pPr>
-              <a:spcAft>
-                <a:spcPts val="1200"/>
-              </a:spcAft>
-              <a:defRPr sz="1800" b="0">
-                <a:solidFill>
-                  <a:srgbClr val="1A1A1A"/>
-                </a:solidFill>
-              </a:defRPr>
-            </a:pPr>
-            <a:r>
-              <a:t>• We report the accuracy delta and the token ratio side by side.</a:t>
-            </a:r>
-          </a:p>
-          <a:p>
-            <a:pPr>
-              <a:spcAft>
-                <a:spcPts val="1200"/>
-              </a:spcAft>
-              <a:defRPr sz="2000" b="1">
-                <a:solidFill>
-                  <a:srgbClr val="B26B00"/>
-                </a:solidFill>
-              </a:defRPr>
-            </a:pPr>
-            <a:r>
-              <a:t>A gain of 2 points for 2.4× the cost is a different finding from a free one.</a:t>
-            </a:r>
-          </a:p>
-          <a:p>
-            <a:pPr>
-              <a:spcAft>
-                <a:spcPts val="1200"/>
-              </a:spcAft>
-              <a:defRPr sz="1800" b="0">
-                <a:solidFill>
-                  <a:srgbClr val="1A1A1A"/>
-                </a:solidFill>
-              </a:defRPr>
-            </a:pPr>
-            <a:r>
-              <a:t>• And we read both against the repeat-to-repeat standard deviation before calling anything an effect.</a:t>
-            </a:r>
-          </a:p>
-        </p:txBody>
-      </p:sp>
+        </p:nvGraphicFramePr>
+        <p:xfrm>
+          <a:off x="640080" y="1554480"/>
+          <a:ext cx="10881360" cy="2487168"/>
+        </p:xfrm>
+        <a:graphic>
+          <a:graphicData uri="http://schemas.openxmlformats.org/drawingml/2006/table">
+            <a:tbl>
+              <a:tblPr firstRow="1" bandRow="1">
+                <a:tableStyleId>{5C22544A-7EE6-4342-B048-85BDC9FD1C3A}</a:tableStyleId>
+              </a:tblPr>
+              <a:tblGrid>
+                <a:gridCol w="3200400"/>
+                <a:gridCol w="1645920"/>
+                <a:gridCol w="1463040"/>
+                <a:gridCol w="1645920"/>
+                <a:gridCol w="1463040"/>
+                <a:gridCol w="1463040"/>
+              </a:tblGrid>
+              <a:tr h="414528">
+                <a:tc>
+                  <a:txBody>
+                    <a:bodyPr/>
+                    <a:lstStyle/>
+                    <a:p>
+                      <a:pPr>
+                        <a:defRPr sz="1300" b="1">
+                          <a:solidFill>
+                            <a:srgbClr val="FFFFFF"/>
+                          </a:solidFill>
+                        </a:defRPr>
+                      </a:pPr>
+                      <a:r>
+                        <a:t>System</a:t>
+                      </a:r>
+                    </a:p>
+                  </a:txBody>
+                  <a:tcPr>
+                    <a:solidFill>
+                      <a:srgbClr val="1F3864"/>
+                    </a:solidFill>
+                  </a:tcPr>
+                </a:tc>
+                <a:tc>
+                  <a:txBody>
+                    <a:bodyPr/>
+                    <a:lstStyle/>
+                    <a:p>
+                      <a:pPr>
+                        <a:defRPr sz="1300" b="1">
+                          <a:solidFill>
+                            <a:srgbClr val="FFFFFF"/>
+                          </a:solidFill>
+                        </a:defRPr>
+                      </a:pPr>
+                      <a:r>
+                        <a:t>Tokens/fc</a:t>
+                      </a:r>
+                    </a:p>
+                  </a:txBody>
+                  <a:tcPr>
+                    <a:solidFill>
+                      <a:srgbClr val="1F3864"/>
+                    </a:solidFill>
+                  </a:tcPr>
+                </a:tc>
+                <a:tc>
+                  <a:txBody>
+                    <a:bodyPr/>
+                    <a:lstStyle/>
+                    <a:p>
+                      <a:pPr>
+                        <a:defRPr sz="1300" b="1">
+                          <a:solidFill>
+                            <a:srgbClr val="FFFFFF"/>
+                          </a:solidFill>
+                        </a:defRPr>
+                      </a:pPr>
+                      <a:r>
+                        <a:t>LLM calls</a:t>
+                      </a:r>
+                    </a:p>
+                  </a:txBody>
+                  <a:tcPr>
+                    <a:solidFill>
+                      <a:srgbClr val="1F3864"/>
+                    </a:solidFill>
+                  </a:tcPr>
+                </a:tc>
+                <a:tc>
+                  <a:txBody>
+                    <a:bodyPr/>
+                    <a:lstStyle/>
+                    <a:p>
+                      <a:pPr>
+                        <a:defRPr sz="1300" b="1">
+                          <a:solidFill>
+                            <a:srgbClr val="FFFFFF"/>
+                          </a:solidFill>
+                        </a:defRPr>
+                      </a:pPr>
+                      <a:r>
+                        <a:t>Wall time</a:t>
+                      </a:r>
+                    </a:p>
+                  </a:txBody>
+                  <a:tcPr>
+                    <a:solidFill>
+                      <a:srgbClr val="1F3864"/>
+                    </a:solidFill>
+                  </a:tcPr>
+                </a:tc>
+                <a:tc>
+                  <a:txBody>
+                    <a:bodyPr/>
+                    <a:lstStyle/>
+                    <a:p>
+                      <a:pPr>
+                        <a:defRPr sz="1300" b="1">
+                          <a:solidFill>
+                            <a:srgbClr val="FFFFFF"/>
+                          </a:solidFill>
+                        </a:defRPr>
+                      </a:pPr>
+                      <a:r>
+                        <a:t>Token ratio</a:t>
+                      </a:r>
+                    </a:p>
+                  </a:txBody>
+                  <a:tcPr>
+                    <a:solidFill>
+                      <a:srgbClr val="1F3864"/>
+                    </a:solidFill>
+                  </a:tcPr>
+                </a:tc>
+                <a:tc>
+                  <a:txBody>
+                    <a:bodyPr/>
+                    <a:lstStyle/>
+                    <a:p>
+                      <a:pPr>
+                        <a:defRPr sz="1300" b="1">
+                          <a:solidFill>
+                            <a:srgbClr val="FFFFFF"/>
+                          </a:solidFill>
+                        </a:defRPr>
+                      </a:pPr>
+                      <a:r>
+                        <a:t>Time ratio</a:t>
+                      </a:r>
+                    </a:p>
+                  </a:txBody>
+                  <a:tcPr>
+                    <a:solidFill>
+                      <a:srgbClr val="1F3864"/>
+                    </a:solidFill>
+                  </a:tcPr>
+                </a:tc>
+              </a:tr>
+              <a:tr h="414528">
+                <a:tc>
+                  <a:txBody>
+                    <a:bodyPr/>
+                    <a:lstStyle/>
+                    <a:p>
+                      <a:pPr>
+                        <a:defRPr sz="1200">
+                          <a:solidFill>
+                            <a:srgbClr val="1A1A1A"/>
+                          </a:solidFill>
+                        </a:defRPr>
+                      </a:pPr>
+                      <a:r>
+                        <a:t>Naive — momentum</a:t>
+                      </a:r>
+                    </a:p>
+                  </a:txBody>
+                  <a:tcPr>
+                    <a:solidFill>
+                      <a:srgbClr val="F7F9FC"/>
+                    </a:solidFill>
+                  </a:tcPr>
+                </a:tc>
+                <a:tc>
+                  <a:txBody>
+                    <a:bodyPr/>
+                    <a:lstStyle/>
+                    <a:p>
+                      <a:pPr>
+                        <a:defRPr sz="1200">
+                          <a:solidFill>
+                            <a:srgbClr val="1A1A1A"/>
+                          </a:solidFill>
+                        </a:defRPr>
+                      </a:pPr>
+                      <a:r>
+                        <a:t>0.0</a:t>
+                      </a:r>
+                    </a:p>
+                  </a:txBody>
+                  <a:tcPr>
+                    <a:solidFill>
+                      <a:srgbClr val="F7F9FC"/>
+                    </a:solidFill>
+                  </a:tcPr>
+                </a:tc>
+                <a:tc>
+                  <a:txBody>
+                    <a:bodyPr/>
+                    <a:lstStyle/>
+                    <a:p>
+                      <a:pPr>
+                        <a:defRPr sz="1200">
+                          <a:solidFill>
+                            <a:srgbClr val="1A1A1A"/>
+                          </a:solidFill>
+                        </a:defRPr>
+                      </a:pPr>
+                      <a:r>
+                        <a:t>0.0</a:t>
+                      </a:r>
+                    </a:p>
+                  </a:txBody>
+                  <a:tcPr>
+                    <a:solidFill>
+                      <a:srgbClr val="F7F9FC"/>
+                    </a:solidFill>
+                  </a:tcPr>
+                </a:tc>
+                <a:tc>
+                  <a:txBody>
+                    <a:bodyPr/>
+                    <a:lstStyle/>
+                    <a:p>
+                      <a:pPr>
+                        <a:defRPr sz="1200">
+                          <a:solidFill>
+                            <a:srgbClr val="1A1A1A"/>
+                          </a:solidFill>
+                        </a:defRPr>
+                      </a:pPr>
+                      <a:r>
+                        <a:t>0.06s</a:t>
+                      </a:r>
+                    </a:p>
+                  </a:txBody>
+                  <a:tcPr>
+                    <a:solidFill>
+                      <a:srgbClr val="F7F9FC"/>
+                    </a:solidFill>
+                  </a:tcPr>
+                </a:tc>
+                <a:tc>
+                  <a:txBody>
+                    <a:bodyPr/>
+                    <a:lstStyle/>
+                    <a:p>
+                      <a:pPr>
+                        <a:defRPr sz="1200">
+                          <a:solidFill>
+                            <a:srgbClr val="1A1A1A"/>
+                          </a:solidFill>
+                        </a:defRPr>
+                      </a:pPr>
+                      <a:r>
+                        <a:t>0.00x</a:t>
+                      </a:r>
+                    </a:p>
+                  </a:txBody>
+                  <a:tcPr>
+                    <a:solidFill>
+                      <a:srgbClr val="F7F9FC"/>
+                    </a:solidFill>
+                  </a:tcPr>
+                </a:tc>
+                <a:tc>
+                  <a:txBody>
+                    <a:bodyPr/>
+                    <a:lstStyle/>
+                    <a:p>
+                      <a:pPr>
+                        <a:defRPr sz="1200">
+                          <a:solidFill>
+                            <a:srgbClr val="1A1A1A"/>
+                          </a:solidFill>
+                        </a:defRPr>
+                      </a:pPr>
+                      <a:r>
+                        <a:t>0.01x</a:t>
+                      </a:r>
+                    </a:p>
+                  </a:txBody>
+                  <a:tcPr>
+                    <a:solidFill>
+                      <a:srgbClr val="F7F9FC"/>
+                    </a:solidFill>
+                  </a:tcPr>
+                </a:tc>
+              </a:tr>
+              <a:tr h="414528">
+                <a:tc>
+                  <a:txBody>
+                    <a:bodyPr/>
+                    <a:lstStyle/>
+                    <a:p>
+                      <a:pPr>
+                        <a:defRPr sz="1200">
+                          <a:solidFill>
+                            <a:srgbClr val="1A1A1A"/>
+                          </a:solidFill>
+                        </a:defRPr>
+                      </a:pPr>
+                      <a:r>
+                        <a:t>Naive — always up</a:t>
+                      </a:r>
+                    </a:p>
+                  </a:txBody>
+                  <a:tcPr>
+                    <a:solidFill>
+                      <a:srgbClr val="FFFFFF"/>
+                    </a:solidFill>
+                  </a:tcPr>
+                </a:tc>
+                <a:tc>
+                  <a:txBody>
+                    <a:bodyPr/>
+                    <a:lstStyle/>
+                    <a:p>
+                      <a:pPr>
+                        <a:defRPr sz="1200">
+                          <a:solidFill>
+                            <a:srgbClr val="1A1A1A"/>
+                          </a:solidFill>
+                        </a:defRPr>
+                      </a:pPr>
+                      <a:r>
+                        <a:t>0.0</a:t>
+                      </a:r>
+                    </a:p>
+                  </a:txBody>
+                  <a:tcPr>
+                    <a:solidFill>
+                      <a:srgbClr val="FFFFFF"/>
+                    </a:solidFill>
+                  </a:tcPr>
+                </a:tc>
+                <a:tc>
+                  <a:txBody>
+                    <a:bodyPr/>
+                    <a:lstStyle/>
+                    <a:p>
+                      <a:pPr>
+                        <a:defRPr sz="1200">
+                          <a:solidFill>
+                            <a:srgbClr val="1A1A1A"/>
+                          </a:solidFill>
+                        </a:defRPr>
+                      </a:pPr>
+                      <a:r>
+                        <a:t>0.0</a:t>
+                      </a:r>
+                    </a:p>
+                  </a:txBody>
+                  <a:tcPr>
+                    <a:solidFill>
+                      <a:srgbClr val="FFFFFF"/>
+                    </a:solidFill>
+                  </a:tcPr>
+                </a:tc>
+                <a:tc>
+                  <a:txBody>
+                    <a:bodyPr/>
+                    <a:lstStyle/>
+                    <a:p>
+                      <a:pPr>
+                        <a:defRPr sz="1200">
+                          <a:solidFill>
+                            <a:srgbClr val="1A1A1A"/>
+                          </a:solidFill>
+                        </a:defRPr>
+                      </a:pPr>
+                      <a:r>
+                        <a:t>0.04s</a:t>
+                      </a:r>
+                    </a:p>
+                  </a:txBody>
+                  <a:tcPr>
+                    <a:solidFill>
+                      <a:srgbClr val="FFFFFF"/>
+                    </a:solidFill>
+                  </a:tcPr>
+                </a:tc>
+                <a:tc>
+                  <a:txBody>
+                    <a:bodyPr/>
+                    <a:lstStyle/>
+                    <a:p>
+                      <a:pPr>
+                        <a:defRPr sz="1200">
+                          <a:solidFill>
+                            <a:srgbClr val="1A1A1A"/>
+                          </a:solidFill>
+                        </a:defRPr>
+                      </a:pPr>
+                      <a:r>
+                        <a:t>0.00x</a:t>
+                      </a:r>
+                    </a:p>
+                  </a:txBody>
+                  <a:tcPr>
+                    <a:solidFill>
+                      <a:srgbClr val="FFFFFF"/>
+                    </a:solidFill>
+                  </a:tcPr>
+                </a:tc>
+                <a:tc>
+                  <a:txBody>
+                    <a:bodyPr/>
+                    <a:lstStyle/>
+                    <a:p>
+                      <a:pPr>
+                        <a:defRPr sz="1200">
+                          <a:solidFill>
+                            <a:srgbClr val="1A1A1A"/>
+                          </a:solidFill>
+                        </a:defRPr>
+                      </a:pPr>
+                      <a:r>
+                        <a:t>0.01x</a:t>
+                      </a:r>
+                    </a:p>
+                  </a:txBody>
+                  <a:tcPr>
+                    <a:solidFill>
+                      <a:srgbClr val="FFFFFF"/>
+                    </a:solidFill>
+                  </a:tcPr>
+                </a:tc>
+              </a:tr>
+              <a:tr h="414528">
+                <a:tc>
+                  <a:txBody>
+                    <a:bodyPr/>
+                    <a:lstStyle/>
+                    <a:p>
+                      <a:pPr>
+                        <a:defRPr sz="1200">
+                          <a:solidFill>
+                            <a:srgbClr val="1A1A1A"/>
+                          </a:solidFill>
+                        </a:defRPr>
+                      </a:pPr>
+                      <a:r>
+                        <a:t>Single-LLM baseline</a:t>
+                      </a:r>
+                    </a:p>
+                  </a:txBody>
+                  <a:tcPr>
+                    <a:solidFill>
+                      <a:srgbClr val="F7F9FC"/>
+                    </a:solidFill>
+                  </a:tcPr>
+                </a:tc>
+                <a:tc>
+                  <a:txBody>
+                    <a:bodyPr/>
+                    <a:lstStyle/>
+                    <a:p>
+                      <a:pPr>
+                        <a:defRPr sz="1200">
+                          <a:solidFill>
+                            <a:srgbClr val="1A1A1A"/>
+                          </a:solidFill>
+                        </a:defRPr>
+                      </a:pPr>
+                      <a:r>
+                        <a:t>4,068.4</a:t>
+                      </a:r>
+                    </a:p>
+                  </a:txBody>
+                  <a:tcPr>
+                    <a:solidFill>
+                      <a:srgbClr val="F7F9FC"/>
+                    </a:solidFill>
+                  </a:tcPr>
+                </a:tc>
+                <a:tc>
+                  <a:txBody>
+                    <a:bodyPr/>
+                    <a:lstStyle/>
+                    <a:p>
+                      <a:pPr>
+                        <a:defRPr sz="1200">
+                          <a:solidFill>
+                            <a:srgbClr val="1A1A1A"/>
+                          </a:solidFill>
+                        </a:defRPr>
+                      </a:pPr>
+                      <a:r>
+                        <a:t>1.0</a:t>
+                      </a:r>
+                    </a:p>
+                  </a:txBody>
+                  <a:tcPr>
+                    <a:solidFill>
+                      <a:srgbClr val="F7F9FC"/>
+                    </a:solidFill>
+                  </a:tcPr>
+                </a:tc>
+                <a:tc>
+                  <a:txBody>
+                    <a:bodyPr/>
+                    <a:lstStyle/>
+                    <a:p>
+                      <a:pPr>
+                        <a:defRPr sz="1200">
+                          <a:solidFill>
+                            <a:srgbClr val="1A1A1A"/>
+                          </a:solidFill>
+                        </a:defRPr>
+                      </a:pPr>
+                      <a:r>
+                        <a:t>6.49s</a:t>
+                      </a:r>
+                    </a:p>
+                  </a:txBody>
+                  <a:tcPr>
+                    <a:solidFill>
+                      <a:srgbClr val="F7F9FC"/>
+                    </a:solidFill>
+                  </a:tcPr>
+                </a:tc>
+                <a:tc>
+                  <a:txBody>
+                    <a:bodyPr/>
+                    <a:lstStyle/>
+                    <a:p>
+                      <a:pPr>
+                        <a:defRPr sz="1200">
+                          <a:solidFill>
+                            <a:srgbClr val="1A1A1A"/>
+                          </a:solidFill>
+                        </a:defRPr>
+                      </a:pPr>
+                      <a:r>
+                        <a:t>1.00x</a:t>
+                      </a:r>
+                    </a:p>
+                  </a:txBody>
+                  <a:tcPr>
+                    <a:solidFill>
+                      <a:srgbClr val="F7F9FC"/>
+                    </a:solidFill>
+                  </a:tcPr>
+                </a:tc>
+                <a:tc>
+                  <a:txBody>
+                    <a:bodyPr/>
+                    <a:lstStyle/>
+                    <a:p>
+                      <a:pPr>
+                        <a:defRPr sz="1200">
+                          <a:solidFill>
+                            <a:srgbClr val="1A1A1A"/>
+                          </a:solidFill>
+                        </a:defRPr>
+                      </a:pPr>
+                      <a:r>
+                        <a:t>1.00x</a:t>
+                      </a:r>
+                    </a:p>
+                  </a:txBody>
+                  <a:tcPr>
+                    <a:solidFill>
+                      <a:srgbClr val="F7F9FC"/>
+                    </a:solidFill>
+                  </a:tcPr>
+                </a:tc>
+              </a:tr>
+              <a:tr h="414528">
+                <a:tc>
+                  <a:txBody>
+                    <a:bodyPr/>
+                    <a:lstStyle/>
+                    <a:p>
+                      <a:pPr>
+                        <a:defRPr sz="1200">
+                          <a:solidFill>
+                            <a:srgbClr val="1A1A1A"/>
+                          </a:solidFill>
+                        </a:defRPr>
+                      </a:pPr>
+                      <a:r>
+                        <a:t>Multi-agent, no debate</a:t>
+                      </a:r>
+                    </a:p>
+                  </a:txBody>
+                  <a:tcPr>
+                    <a:solidFill>
+                      <a:srgbClr val="FFFFFF"/>
+                    </a:solidFill>
+                  </a:tcPr>
+                </a:tc>
+                <a:tc>
+                  <a:txBody>
+                    <a:bodyPr/>
+                    <a:lstStyle/>
+                    <a:p>
+                      <a:pPr>
+                        <a:defRPr sz="1200">
+                          <a:solidFill>
+                            <a:srgbClr val="1A1A1A"/>
+                          </a:solidFill>
+                        </a:defRPr>
+                      </a:pPr>
+                      <a:r>
+                        <a:t>9,185.6</a:t>
+                      </a:r>
+                    </a:p>
+                  </a:txBody>
+                  <a:tcPr>
+                    <a:solidFill>
+                      <a:srgbClr val="FFFFFF"/>
+                    </a:solidFill>
+                  </a:tcPr>
+                </a:tc>
+                <a:tc>
+                  <a:txBody>
+                    <a:bodyPr/>
+                    <a:lstStyle/>
+                    <a:p>
+                      <a:pPr>
+                        <a:defRPr sz="1200">
+                          <a:solidFill>
+                            <a:srgbClr val="1A1A1A"/>
+                          </a:solidFill>
+                        </a:defRPr>
+                      </a:pPr>
+                      <a:r>
+                        <a:t>4.9</a:t>
+                      </a:r>
+                    </a:p>
+                  </a:txBody>
+                  <a:tcPr>
+                    <a:solidFill>
+                      <a:srgbClr val="FFFFFF"/>
+                    </a:solidFill>
+                  </a:tcPr>
+                </a:tc>
+                <a:tc>
+                  <a:txBody>
+                    <a:bodyPr/>
+                    <a:lstStyle/>
+                    <a:p>
+                      <a:pPr>
+                        <a:defRPr sz="1200">
+                          <a:solidFill>
+                            <a:srgbClr val="1A1A1A"/>
+                          </a:solidFill>
+                        </a:defRPr>
+                      </a:pPr>
+                      <a:r>
+                        <a:t>7.46s</a:t>
+                      </a:r>
+                    </a:p>
+                  </a:txBody>
+                  <a:tcPr>
+                    <a:solidFill>
+                      <a:srgbClr val="FFFFFF"/>
+                    </a:solidFill>
+                  </a:tcPr>
+                </a:tc>
+                <a:tc>
+                  <a:txBody>
+                    <a:bodyPr/>
+                    <a:lstStyle/>
+                    <a:p>
+                      <a:pPr>
+                        <a:defRPr sz="1200">
+                          <a:solidFill>
+                            <a:srgbClr val="1A1A1A"/>
+                          </a:solidFill>
+                        </a:defRPr>
+                      </a:pPr>
+                      <a:r>
+                        <a:t>2.26x</a:t>
+                      </a:r>
+                    </a:p>
+                  </a:txBody>
+                  <a:tcPr>
+                    <a:solidFill>
+                      <a:srgbClr val="FFFFFF"/>
+                    </a:solidFill>
+                  </a:tcPr>
+                </a:tc>
+                <a:tc>
+                  <a:txBody>
+                    <a:bodyPr/>
+                    <a:lstStyle/>
+                    <a:p>
+                      <a:pPr>
+                        <a:defRPr sz="1200">
+                          <a:solidFill>
+                            <a:srgbClr val="1A1A1A"/>
+                          </a:solidFill>
+                        </a:defRPr>
+                      </a:pPr>
+                      <a:r>
+                        <a:t>1.15x</a:t>
+                      </a:r>
+                    </a:p>
+                  </a:txBody>
+                  <a:tcPr>
+                    <a:solidFill>
+                      <a:srgbClr val="FFFFFF"/>
+                    </a:solidFill>
+                  </a:tcPr>
+                </a:tc>
+              </a:tr>
+              <a:tr h="414528">
+                <a:tc>
+                  <a:txBody>
+                    <a:bodyPr/>
+                    <a:lstStyle/>
+                    <a:p>
+                      <a:pPr>
+                        <a:defRPr sz="1200">
+                          <a:solidFill>
+                            <a:srgbClr val="1A1A1A"/>
+                          </a:solidFill>
+                        </a:defRPr>
+                      </a:pPr>
+                      <a:r>
+                        <a:t>Multi-agent + debate</a:t>
+                      </a:r>
+                    </a:p>
+                  </a:txBody>
+                  <a:tcPr>
+                    <a:solidFill>
+                      <a:srgbClr val="F7F9FC"/>
+                    </a:solidFill>
+                  </a:tcPr>
+                </a:tc>
+                <a:tc>
+                  <a:txBody>
+                    <a:bodyPr/>
+                    <a:lstStyle/>
+                    <a:p>
+                      <a:pPr>
+                        <a:defRPr sz="1200">
+                          <a:solidFill>
+                            <a:srgbClr val="1A1A1A"/>
+                          </a:solidFill>
+                        </a:defRPr>
+                      </a:pPr>
+                      <a:r>
+                        <a:t>19,696.2</a:t>
+                      </a:r>
+                    </a:p>
+                  </a:txBody>
+                  <a:tcPr>
+                    <a:solidFill>
+                      <a:srgbClr val="F7F9FC"/>
+                    </a:solidFill>
+                  </a:tcPr>
+                </a:tc>
+                <a:tc>
+                  <a:txBody>
+                    <a:bodyPr/>
+                    <a:lstStyle/>
+                    <a:p>
+                      <a:pPr>
+                        <a:defRPr sz="1200">
+                          <a:solidFill>
+                            <a:srgbClr val="1A1A1A"/>
+                          </a:solidFill>
+                        </a:defRPr>
+                      </a:pPr>
+                      <a:r>
+                        <a:t>9.0</a:t>
+                      </a:r>
+                    </a:p>
+                  </a:txBody>
+                  <a:tcPr>
+                    <a:solidFill>
+                      <a:srgbClr val="F7F9FC"/>
+                    </a:solidFill>
+                  </a:tcPr>
+                </a:tc>
+                <a:tc>
+                  <a:txBody>
+                    <a:bodyPr/>
+                    <a:lstStyle/>
+                    <a:p>
+                      <a:pPr>
+                        <a:defRPr sz="1200">
+                          <a:solidFill>
+                            <a:srgbClr val="1A1A1A"/>
+                          </a:solidFill>
+                        </a:defRPr>
+                      </a:pPr>
+                      <a:r>
+                        <a:t>53.63s</a:t>
+                      </a:r>
+                    </a:p>
+                  </a:txBody>
+                  <a:tcPr>
+                    <a:solidFill>
+                      <a:srgbClr val="F7F9FC"/>
+                    </a:solidFill>
+                  </a:tcPr>
+                </a:tc>
+                <a:tc>
+                  <a:txBody>
+                    <a:bodyPr/>
+                    <a:lstStyle/>
+                    <a:p>
+                      <a:pPr>
+                        <a:defRPr sz="1200">
+                          <a:solidFill>
+                            <a:srgbClr val="1A1A1A"/>
+                          </a:solidFill>
+                        </a:defRPr>
+                      </a:pPr>
+                      <a:r>
+                        <a:t>4.84x</a:t>
+                      </a:r>
+                    </a:p>
+                  </a:txBody>
+                  <a:tcPr>
+                    <a:solidFill>
+                      <a:srgbClr val="F7F9FC"/>
+                    </a:solidFill>
+                  </a:tcPr>
+                </a:tc>
+                <a:tc>
+                  <a:txBody>
+                    <a:bodyPr/>
+                    <a:lstStyle/>
+                    <a:p>
+                      <a:pPr>
+                        <a:defRPr sz="1200">
+                          <a:solidFill>
+                            <a:srgbClr val="1A1A1A"/>
+                          </a:solidFill>
+                        </a:defRPr>
+                      </a:pPr>
+                      <a:r>
+                        <a:t>8.26x</a:t>
+                      </a:r>
+                    </a:p>
+                  </a:txBody>
+                  <a:tcPr>
+                    <a:solidFill>
+                      <a:srgbClr val="F7F9FC"/>
+                    </a:solidFill>
+                  </a:tcPr>
+                </a:tc>
+              </a:tr>
+            </a:tbl>
+          </a:graphicData>
+        </a:graphic>
+      </p:graphicFrame>
     </p:spTree>
   </p:cSld>
   <p:clrMapOvr>
@@ -7309,7 +8430,7 @@
               </a:defRPr>
             </a:pPr>
             <a:r>
-              <a:t>What we do NOT claim</a:t>
+              <a:t>Pre-registered hypothesis tests (decision rules)</a:t>
             </a:r>
           </a:p>
         </p:txBody>
@@ -7367,6 +8488,41 @@
         <p:spPr>
           <a:xfrm>
             <a:off x="640080" y="1463040"/>
+            <a:ext cx="10881360" cy="548640"/>
+          </a:xfrm>
+          <a:prstGeom prst="rect">
+            <a:avLst/>
+          </a:prstGeom>
+          <a:noFill/>
+        </p:spPr>
+        <p:txBody>
+          <a:bodyPr wrap="square">
+            <a:spAutoFit/>
+          </a:bodyPr>
+          <a:lstStyle/>
+          <a:p>
+            <a:pPr>
+              <a:defRPr sz="1600" i="1">
+                <a:solidFill>
+                  <a:srgbClr val="6B7280"/>
+                </a:solidFill>
+              </a:defRPr>
+            </a:pPr>
+            <a:r>
+              <a:t>Strict compliance with pre-registered decision rules</a:t>
+            </a:r>
+          </a:p>
+        </p:txBody>
+      </p:sp>
+      <p:sp>
+        <p:nvSpPr>
+          <p:cNvPr id="5" name="TextBox 4"/>
+          <p:cNvSpPr txBox="1"/>
+          <p:nvPr/>
+        </p:nvSpPr>
+        <p:spPr>
+          <a:xfrm>
+            <a:off x="640080" y="2057400"/>
             <a:ext cx="10881360" cy="4206240"/>
           </a:xfrm>
           <a:prstGeom prst="rect">
@@ -7384,14 +8540,14 @@
               <a:spcAft>
                 <a:spcPts val="1200"/>
               </a:spcAft>
-              <a:defRPr sz="1800" b="0">
+              <a:defRPr sz="1600" b="0">
                 <a:solidFill>
                   <a:srgbClr val="1A1A1A"/>
                 </a:solidFill>
               </a:defRPr>
             </a:pPr>
             <a:r>
-              <a:t>• Restatement leakage remains — yfinance serves restated financials.</a:t>
+              <a:t>• Primary Comparison: Multi-Agent with Debate vs Single-LLM Baseline:</a:t>
             </a:r>
           </a:p>
           <a:p>
@@ -7399,14 +8555,29 @@
               <a:spcAft>
                 <a:spcPts val="600"/>
               </a:spcAft>
-              <a:defRPr sz="1600" b="0">
+              <a:defRPr sz="1400" b="0">
                 <a:solidFill>
                   <a:srgbClr val="6B7280"/>
                 </a:solidFill>
               </a:defRPr>
             </a:pPr>
             <a:r>
-              <a:t>• The 45-day rule fixes TIMING leakage, not restatement leakage.</a:t>
+              <a:t>• Point delta: +8.82 percentage points (50.00% vs 41.18%)</a:t>
+            </a:r>
+          </a:p>
+          <a:p>
+            <a:pPr lvl="1">
+              <a:spcAft>
+                <a:spcPts val="600"/>
+              </a:spcAft>
+              <a:defRPr sz="1400" b="0">
+                <a:solidFill>
+                  <a:srgbClr val="6B7280"/>
+                </a:solidFill>
+              </a:defRPr>
+            </a:pPr>
+            <a:r>
+              <a:t>• 95% Date-Block Clustered CI: [-4.41, +22.06] pts (McNemar exact p = 0.2863)</a:t>
             </a:r>
           </a:p>
           <a:p>
@@ -7414,14 +8585,14 @@
               <a:spcAft>
                 <a:spcPts val="1200"/>
               </a:spcAft>
-              <a:defRPr sz="1800" b="0">
-                <a:solidFill>
-                  <a:srgbClr val="1A1A1A"/>
-                </a:solidFill>
-              </a:defRPr>
-            </a:pPr>
-            <a:r>
-              <a:t>• India CPI is unavailable free — documented, never estimated.</a:t>
+              <a:defRPr sz="1800" b="1">
+                <a:solidFill>
+                  <a:srgbClr val="B26B00"/>
+                </a:solidFill>
+              </a:defRPr>
+            </a:pPr>
+            <a:r>
+              <a:t>Pre-registered verdict: NO SUPPORTED DIFFERENCE (CI spans 0; not an improvement).</a:t>
             </a:r>
           </a:p>
           <a:p>
@@ -7429,14 +8600,44 @@
               <a:spcAft>
                 <a:spcPts val="1200"/>
               </a:spcAft>
-              <a:defRPr sz="1800" b="0">
+              <a:defRPr sz="1600" b="0">
                 <a:solidFill>
                   <a:srgbClr val="1A1A1A"/>
                 </a:solidFill>
               </a:defRPr>
             </a:pPr>
             <a:r>
-              <a:t>• GDELT gives headline metadata and tone, not article text.</a:t>
+              <a:t>• Debate Ablation: Multi-Agent with Debate vs Multi-Agent without Debate:</a:t>
+            </a:r>
+          </a:p>
+          <a:p>
+            <a:pPr lvl="1">
+              <a:spcAft>
+                <a:spcPts val="600"/>
+              </a:spcAft>
+              <a:defRPr sz="1400" b="0">
+                <a:solidFill>
+                  <a:srgbClr val="6B7280"/>
+                </a:solidFill>
+              </a:defRPr>
+            </a:pPr>
+            <a:r>
+              <a:t>• Point delta: +4.41 percentage points (50.00% vs 45.59%)</a:t>
+            </a:r>
+          </a:p>
+          <a:p>
+            <a:pPr lvl="1">
+              <a:spcAft>
+                <a:spcPts val="600"/>
+              </a:spcAft>
+              <a:defRPr sz="1400" b="0">
+                <a:solidFill>
+                  <a:srgbClr val="6B7280"/>
+                </a:solidFill>
+              </a:defRPr>
+            </a:pPr>
+            <a:r>
+              <a:t>• 95% Date-Block Clustered CI: [-2.94, +13.24] pts (McNemar exact p = 0.5488)</a:t>
             </a:r>
           </a:p>
           <a:p>
@@ -7444,14 +8645,14 @@
               <a:spcAft>
                 <a:spcPts val="1200"/>
               </a:spcAft>
-              <a:defRPr sz="1800" b="0">
-                <a:solidFill>
-                  <a:srgbClr val="1A1A1A"/>
-                </a:solidFill>
-              </a:defRPr>
-            </a:pPr>
-            <a:r>
-              <a:t>• The test set is small — differences of a few points sit inside noise.</a:t>
+              <a:defRPr sz="1800" b="1">
+                <a:solidFill>
+                  <a:srgbClr val="B26B00"/>
+                </a:solidFill>
+              </a:defRPr>
+            </a:pPr>
+            <a:r>
+              <a:t>Pre-registered verdict: NO SUPPORTED DIFFERENCE (CI spans 0; not an improvement).</a:t>
             </a:r>
           </a:p>
           <a:p>
@@ -7459,14 +8660,14 @@
               <a:spcAft>
                 <a:spcPts val="1200"/>
               </a:spcAft>
-              <a:defRPr sz="2000" b="1">
-                <a:solidFill>
-                  <a:srgbClr val="B26B00"/>
-                </a:solidFill>
-              </a:defRPr>
-            </a:pPr>
-            <a:r>
-              <a:t>Every one of these is in the report. None was discovered by an examiner.</a:t>
+              <a:defRPr sz="1600" b="0">
+                <a:solidFill>
+                  <a:srgbClr val="1A1A1A"/>
+                </a:solidFill>
+              </a:defRPr>
+            </a:pPr>
+            <a:r>
+              <a:t>• Calibration Payoff: Brier improves from 0.2880 to 0.2593 (overconfidence gap cut 19.5 -&gt; 10.7 pts).</a:t>
             </a:r>
           </a:p>
         </p:txBody>
@@ -7714,7 +8915,7 @@
               </a:defRPr>
             </a:pPr>
             <a:r>
-              <a:t>Conclusion</a:t>
+              <a:t>What we do NOT claim (Limitations)</a:t>
             </a:r>
           </a:p>
         </p:txBody>
@@ -7796,7 +8997,22 @@
               </a:defRPr>
             </a:pPr>
             <a:r>
-              <a:t>• Built: a 7-agent forecasting system for NSE equities, end to end.</a:t>
+              <a:t>• Restatement leakage remains — yfinance serves restated financials.</a:t>
+            </a:r>
+          </a:p>
+          <a:p>
+            <a:pPr lvl="1">
+              <a:spcAft>
+                <a:spcPts val="600"/>
+              </a:spcAft>
+              <a:defRPr sz="1600" b="0">
+                <a:solidFill>
+                  <a:srgbClr val="6B7280"/>
+                </a:solidFill>
+              </a:defRPr>
+            </a:pPr>
+            <a:r>
+              <a:t>• The 45-day rule fixes TIMING leakage, not restatement leakage.</a:t>
             </a:r>
           </a:p>
           <a:p>
@@ -7811,6 +9027,201 @@
               </a:defRPr>
             </a:pPr>
             <a:r>
+              <a:t>• India CPI is unavailable free — documented, never estimated.</a:t>
+            </a:r>
+          </a:p>
+          <a:p>
+            <a:pPr>
+              <a:spcAft>
+                <a:spcPts val="1200"/>
+              </a:spcAft>
+              <a:defRPr sz="1800" b="0">
+                <a:solidFill>
+                  <a:srgbClr val="1A1A1A"/>
+                </a:solidFill>
+              </a:defRPr>
+            </a:pPr>
+            <a:r>
+              <a:t>• GDELT gives headline metadata and tone, not full article text.</a:t>
+            </a:r>
+          </a:p>
+          <a:p>
+            <a:pPr>
+              <a:spcAft>
+                <a:spcPts val="1200"/>
+              </a:spcAft>
+              <a:defRPr sz="1800" b="0">
+                <a:solidFill>
+                  <a:srgbClr val="1A1A1A"/>
+                </a:solidFill>
+              </a:defRPr>
+            </a:pPr>
+            <a:r>
+              <a:t>• Sample size (N=68 across 4 date clusters) yields wide confidence intervals.</a:t>
+            </a:r>
+          </a:p>
+          <a:p>
+            <a:pPr>
+              <a:spcAft>
+                <a:spcPts val="1200"/>
+              </a:spcAft>
+              <a:defRPr sz="2000" b="1">
+                <a:solidFill>
+                  <a:srgbClr val="B26B00"/>
+                </a:solidFill>
+              </a:defRPr>
+            </a:pPr>
+            <a:r>
+              <a:t>Every limitation is documented upfront in docs/LIMITATIONS.md.</a:t>
+            </a:r>
+          </a:p>
+        </p:txBody>
+      </p:sp>
+    </p:spTree>
+  </p:cSld>
+  <p:clrMapOvr>
+    <a:masterClrMapping/>
+  </p:clrMapOvr>
+</p:sld>
+</file>
+
+<file path=ppt/slides/slide21.xml><?xml version="1.0" encoding="utf-8"?>
+<p:sld xmlns:a="http://schemas.openxmlformats.org/drawingml/2006/main" xmlns:p="http://schemas.openxmlformats.org/presentationml/2006/main" xmlns:r="http://schemas.openxmlformats.org/officeDocument/2006/relationships">
+  <p:cSld>
+    <p:spTree>
+      <p:nvGrpSpPr>
+        <p:cNvPr id="1" name=""/>
+        <p:cNvGrpSpPr/>
+        <p:nvPr/>
+      </p:nvGrpSpPr>
+      <p:grpSpPr/>
+      <p:sp>
+        <p:nvSpPr>
+          <p:cNvPr id="2" name="TextBox 1"/>
+          <p:cNvSpPr txBox="1"/>
+          <p:nvPr/>
+        </p:nvSpPr>
+        <p:spPr>
+          <a:xfrm>
+            <a:off x="640080" y="457200"/>
+            <a:ext cx="10881360" cy="822960"/>
+          </a:xfrm>
+          <a:prstGeom prst="rect">
+            <a:avLst/>
+          </a:prstGeom>
+          <a:noFill/>
+        </p:spPr>
+        <p:txBody>
+          <a:bodyPr wrap="square">
+            <a:spAutoFit/>
+          </a:bodyPr>
+          <a:lstStyle/>
+          <a:p>
+            <a:pPr>
+              <a:defRPr sz="2800" b="1">
+                <a:solidFill>
+                  <a:srgbClr val="1F3864"/>
+                </a:solidFill>
+              </a:defRPr>
+            </a:pPr>
+            <a:r>
+              <a:t>Conclusion</a:t>
+            </a:r>
+          </a:p>
+        </p:txBody>
+      </p:sp>
+      <p:sp>
+        <p:nvSpPr>
+          <p:cNvPr id="3" name="Rectangle 2"/>
+          <p:cNvSpPr/>
+          <p:nvPr/>
+        </p:nvSpPr>
+        <p:spPr>
+          <a:xfrm>
+            <a:off x="640080" y="1170432"/>
+            <a:ext cx="10881360" cy="22860"/>
+          </a:xfrm>
+          <a:prstGeom prst="rect">
+            <a:avLst/>
+          </a:prstGeom>
+          <a:solidFill>
+            <a:srgbClr val="1F3864"/>
+          </a:solidFill>
+          <a:ln>
+            <a:noFill/>
+          </a:ln>
+          <a:effectLst/>
+        </p:spPr>
+        <p:style>
+          <a:lnRef idx="1">
+            <a:schemeClr val="accent1"/>
+          </a:lnRef>
+          <a:fillRef idx="3">
+            <a:schemeClr val="accent1"/>
+          </a:fillRef>
+          <a:effectRef idx="2">
+            <a:schemeClr val="accent1"/>
+          </a:effectRef>
+          <a:fontRef idx="minor">
+            <a:schemeClr val="lt1"/>
+          </a:fontRef>
+        </p:style>
+        <p:txBody>
+          <a:bodyPr rtlCol="0" anchor="ctr"/>
+          <a:lstStyle/>
+          <a:p>
+            <a:pPr algn="ctr"/>
+          </a:p>
+        </p:txBody>
+      </p:sp>
+      <p:sp>
+        <p:nvSpPr>
+          <p:cNvPr id="4" name="TextBox 3"/>
+          <p:cNvSpPr txBox="1"/>
+          <p:nvPr/>
+        </p:nvSpPr>
+        <p:spPr>
+          <a:xfrm>
+            <a:off x="640080" y="1463040"/>
+            <a:ext cx="10881360" cy="4206240"/>
+          </a:xfrm>
+          <a:prstGeom prst="rect">
+            <a:avLst/>
+          </a:prstGeom>
+          <a:noFill/>
+        </p:spPr>
+        <p:txBody>
+          <a:bodyPr wrap="square">
+            <a:spAutoFit/>
+          </a:bodyPr>
+          <a:lstStyle/>
+          <a:p>
+            <a:pPr>
+              <a:spcAft>
+                <a:spcPts val="1200"/>
+              </a:spcAft>
+              <a:defRPr sz="1800" b="0">
+                <a:solidFill>
+                  <a:srgbClr val="1A1A1A"/>
+                </a:solidFill>
+              </a:defRPr>
+            </a:pPr>
+            <a:r>
+              <a:t>• Built: a 7-agent forecasting system for NSE equities, end to end.</a:t>
+            </a:r>
+          </a:p>
+          <a:p>
+            <a:pPr>
+              <a:spcAft>
+                <a:spcPts val="1200"/>
+              </a:spcAft>
+              <a:defRPr sz="1800" b="0">
+                <a:solidFill>
+                  <a:srgbClr val="1A1A1A"/>
+                </a:solidFill>
+              </a:defRPr>
+            </a:pPr>
+            <a:r>
               <a:t>• Built first: the evaluation protocol that makes its results mean anything.</a:t>
             </a:r>
           </a:p>
@@ -7826,7 +9237,7 @@
               </a:defRPr>
             </a:pPr>
             <a:r>
-              <a:t>• as_of in the data layer · quarantined outcomes · point-in-time universe · SEBI lag · reconciliation gate</a:t>
+              <a:t>• as_of in data layer · quarantined outcomes · point-in-time universe · SEBI lag · reconciliation gate</a:t>
             </a:r>
           </a:p>
           <a:p>

</xml_diff>